<commit_message>
World Kindness Day: mustard instead of brown
</commit_message>
<xml_diff>
--- a/assemblies-and-events/world-kindness-day/downloads/World_Kindness_Day_Assembly.pptx
+++ b/assemblies-and-events/world-kindness-day/downloads/World_Kindness_Day_Assembly.pptx
@@ -3113,7 +3113,7 @@
             <a:avLst/>
           </a:prstGeom>
           <a:solidFill>
-            <a:srgbClr val="F8F1E2"/>
+            <a:srgbClr val="F3DA8C"/>
           </a:solidFill>
           <a:ln>
             <a:noFill/>
@@ -3199,7 +3199,7 @@
             <a:r>
               <a:rPr sz="4400" b="1" i="0">
                 <a:solidFill>
-                  <a:srgbClr val="8A6420"/>
+                  <a:srgbClr val="3A3320"/>
                 </a:solidFill>
                 <a:latin typeface="Libre Caslon Display"/>
               </a:rPr>
@@ -3223,7 +3223,7 @@
             <a:avLst/>
           </a:prstGeom>
           <a:solidFill>
-            <a:srgbClr val="C59A45"/>
+            <a:srgbClr val="A8770F"/>
           </a:solidFill>
           <a:ln>
             <a:noFill/>
@@ -3327,7 +3327,7 @@
             <a:r>
               <a:rPr sz="1300" b="0" i="0">
                 <a:solidFill>
-                  <a:srgbClr val="8B9179"/>
+                  <a:srgbClr val="5C6552"/>
                 </a:solidFill>
                 <a:latin typeface="Karla"/>
               </a:rPr>
@@ -3393,7 +3393,7 @@
             <a:r>
               <a:rPr sz="850" b="0" i="1">
                 <a:solidFill>
-                  <a:srgbClr val="8B9179"/>
+                  <a:srgbClr val="5C6552"/>
                 </a:solidFill>
                 <a:latin typeface="Karla"/>
               </a:rPr>
@@ -3435,7 +3435,7 @@
             <a:r>
               <a:rPr sz="850" b="0" i="0">
                 <a:solidFill>
-                  <a:srgbClr val="8B9179"/>
+                  <a:srgbClr val="5C6552"/>
                 </a:solidFill>
                 <a:latin typeface="Karla"/>
               </a:rPr>
@@ -3477,7 +3477,7 @@
             <a:avLst/>
           </a:prstGeom>
           <a:solidFill>
-            <a:srgbClr val="8A6420"/>
+            <a:srgbClr val="F3DA8C"/>
           </a:solidFill>
           <a:ln>
             <a:noFill/>
@@ -3539,7 +3539,7 @@
             <a:r>
               <a:rPr sz="2800" b="1" i="0">
                 <a:solidFill>
-                  <a:srgbClr val="FFFDF7"/>
+                  <a:srgbClr val="3A3320"/>
                 </a:solidFill>
                 <a:latin typeface="Libre Caslon Display"/>
               </a:rPr>
@@ -3561,7 +3561,7 @@
             <a:r>
               <a:rPr sz="2800" b="1" i="0">
                 <a:solidFill>
-                  <a:srgbClr val="FFFDF7"/>
+                  <a:srgbClr val="3A3320"/>
                 </a:solidFill>
                 <a:latin typeface="Libre Caslon Display"/>
               </a:rPr>
@@ -3585,7 +3585,7 @@
             <a:avLst/>
           </a:prstGeom>
           <a:solidFill>
-            <a:srgbClr val="EAD8AE"/>
+            <a:srgbClr val="A8770F"/>
           </a:solidFill>
           <a:ln>
             <a:noFill/>
@@ -3647,7 +3647,7 @@
             <a:r>
               <a:rPr sz="1350" b="0" i="0">
                 <a:solidFill>
-                  <a:srgbClr val="EAD8AE"/>
+                  <a:srgbClr val="5C6552"/>
                 </a:solidFill>
                 <a:latin typeface="Karla"/>
               </a:rPr>
@@ -3713,7 +3713,7 @@
             <a:r>
               <a:rPr sz="850" b="0" i="1">
                 <a:solidFill>
-                  <a:srgbClr val="EAD8AE"/>
+                  <a:srgbClr val="5C6552"/>
                 </a:solidFill>
                 <a:latin typeface="Karla"/>
               </a:rPr>
@@ -3755,7 +3755,7 @@
             <a:r>
               <a:rPr sz="850" b="0" i="0">
                 <a:solidFill>
-                  <a:srgbClr val="EAD8AE"/>
+                  <a:srgbClr val="5C6552"/>
                 </a:solidFill>
                 <a:latin typeface="Karla"/>
               </a:rPr>
@@ -3797,7 +3797,7 @@
             <a:avLst/>
           </a:prstGeom>
           <a:solidFill>
-            <a:srgbClr val="F8F1E2"/>
+            <a:srgbClr val="F3DA8C"/>
           </a:solidFill>
           <a:ln>
             <a:noFill/>
@@ -3883,7 +3883,7 @@
             <a:r>
               <a:rPr sz="3200" b="1" i="0">
                 <a:solidFill>
-                  <a:srgbClr val="8A6420"/>
+                  <a:srgbClr val="3A3320"/>
                 </a:solidFill>
                 <a:latin typeface="Libre Caslon Display"/>
               </a:rPr>
@@ -3967,7 +3967,7 @@
             <a:r>
               <a:rPr sz="1200" b="0" i="0">
                 <a:solidFill>
-                  <a:srgbClr val="8B9179"/>
+                  <a:srgbClr val="5C6552"/>
                 </a:solidFill>
                 <a:latin typeface="Karla"/>
               </a:rPr>
@@ -4033,7 +4033,7 @@
             <a:r>
               <a:rPr sz="850" b="0" i="1">
                 <a:solidFill>
-                  <a:srgbClr val="8B9179"/>
+                  <a:srgbClr val="5C6552"/>
                 </a:solidFill>
                 <a:latin typeface="Karla"/>
               </a:rPr>
@@ -4075,7 +4075,7 @@
             <a:r>
               <a:rPr sz="850" b="0" i="0">
                 <a:solidFill>
-                  <a:srgbClr val="8B9179"/>
+                  <a:srgbClr val="5C6552"/>
                 </a:solidFill>
                 <a:latin typeface="Karla"/>
               </a:rPr>
@@ -4117,7 +4117,7 @@
             <a:avLst/>
           </a:prstGeom>
           <a:solidFill>
-            <a:srgbClr val="8A6420"/>
+            <a:srgbClr val="F3DA8C"/>
           </a:solidFill>
           <a:ln>
             <a:noFill/>
@@ -4179,7 +4179,7 @@
             <a:r>
               <a:rPr sz="2800" b="1" i="0">
                 <a:solidFill>
-                  <a:srgbClr val="FFFDF7"/>
+                  <a:srgbClr val="3A3320"/>
                 </a:solidFill>
                 <a:latin typeface="Libre Caslon Display"/>
               </a:rPr>
@@ -4201,7 +4201,7 @@
             <a:r>
               <a:rPr sz="2800" b="1" i="0">
                 <a:solidFill>
-                  <a:srgbClr val="FFFDF7"/>
+                  <a:srgbClr val="3A3320"/>
                 </a:solidFill>
                 <a:latin typeface="Libre Caslon Display"/>
               </a:rPr>
@@ -4225,7 +4225,7 @@
             <a:avLst/>
           </a:prstGeom>
           <a:solidFill>
-            <a:srgbClr val="EAD8AE"/>
+            <a:srgbClr val="A8770F"/>
           </a:solidFill>
           <a:ln>
             <a:noFill/>
@@ -4287,7 +4287,7 @@
             <a:r>
               <a:rPr sz="1350" b="0" i="0">
                 <a:solidFill>
-                  <a:srgbClr val="EAD8AE"/>
+                  <a:srgbClr val="5C6552"/>
                 </a:solidFill>
                 <a:latin typeface="Karla"/>
               </a:rPr>
@@ -4353,7 +4353,7 @@
             <a:r>
               <a:rPr sz="850" b="0" i="1">
                 <a:solidFill>
-                  <a:srgbClr val="EAD8AE"/>
+                  <a:srgbClr val="5C6552"/>
                 </a:solidFill>
                 <a:latin typeface="Karla"/>
               </a:rPr>
@@ -4395,7 +4395,7 @@
             <a:r>
               <a:rPr sz="850" b="0" i="0">
                 <a:solidFill>
-                  <a:srgbClr val="EAD8AE"/>
+                  <a:srgbClr val="5C6552"/>
                 </a:solidFill>
                 <a:latin typeface="Karla"/>
               </a:rPr>
@@ -4499,7 +4499,7 @@
             <a:r>
               <a:rPr sz="1050" b="1" i="0" spc="160">
                 <a:solidFill>
-                  <a:srgbClr val="8A6420"/>
+                  <a:srgbClr val="3A3320"/>
                 </a:solidFill>
                 <a:latin typeface="Karla"/>
               </a:rPr>
@@ -4609,7 +4609,7 @@
             </a:avLst>
           </a:prstGeom>
           <a:solidFill>
-            <a:srgbClr val="F8F1E2"/>
+            <a:srgbClr val="FBF3DD"/>
           </a:solidFill>
           <a:ln>
             <a:noFill/>
@@ -4653,7 +4653,7 @@
             <a:avLst/>
           </a:prstGeom>
           <a:solidFill>
-            <a:srgbClr val="C59A45"/>
+            <a:srgbClr val="DBA62F"/>
           </a:solidFill>
           <a:ln>
             <a:noFill/>
@@ -4741,7 +4741,7 @@
                 </a:solidFill>
                 <a:latin typeface="Karla"/>
               </a:rPr>
-              <a:t>This week: five minutes in form time each day, ending on World Kindness Day.</a:t>
+              <a:t>This week: five minutes of form time a day, ending on Friday.</a:t>
             </a:r>
           </a:p>
         </p:txBody>
@@ -4991,7 +4991,7 @@
             <a:r>
               <a:rPr sz="1050" b="1" i="0" spc="160">
                 <a:solidFill>
-                  <a:srgbClr val="8A6420"/>
+                  <a:srgbClr val="3A3320"/>
                 </a:solidFill>
                 <a:latin typeface="Karla"/>
               </a:rPr>
@@ -5163,7 +5163,7 @@
             <a:r>
               <a:rPr sz="4600" b="1" i="0">
                 <a:solidFill>
-                  <a:srgbClr val="8A6420"/>
+                  <a:srgbClr val="3A3320"/>
                 </a:solidFill>
                 <a:latin typeface="Libre Caslon Display"/>
               </a:rPr>
@@ -5209,7 +5209,7 @@
                 </a:solidFill>
                 <a:latin typeface="Karla"/>
               </a:rPr>
-              <a:t>how big the people giving it thought it was</a:t>
+              <a:t>how big the givers thought it was</a:t>
             </a:r>
           </a:p>
         </p:txBody>
@@ -5231,7 +5231,7 @@
             </a:avLst>
           </a:prstGeom>
           <a:solidFill>
-            <a:srgbClr val="8A6420"/>
+            <a:srgbClr val="DBA62F"/>
           </a:solidFill>
           <a:ln>
             <a:noFill/>
@@ -5293,7 +5293,7 @@
             <a:r>
               <a:rPr sz="4600" b="1" i="0">
                 <a:solidFill>
-                  <a:srgbClr val="FFFDF7"/>
+                  <a:srgbClr val="3A3320"/>
                 </a:solidFill>
                 <a:latin typeface="Libre Caslon Display"/>
               </a:rPr>
@@ -5335,7 +5335,7 @@
             <a:r>
               <a:rPr sz="1300" b="0" i="0">
                 <a:solidFill>
-                  <a:srgbClr val="EAD8AE"/>
+                  <a:srgbClr val="3A3320"/>
                 </a:solidFill>
                 <a:latin typeface="Karla"/>
               </a:rPr>
@@ -5377,7 +5377,7 @@
             <a:r>
               <a:rPr sz="1200" b="0" i="1">
                 <a:solidFill>
-                  <a:srgbClr val="8A6420"/>
+                  <a:srgbClr val="3A3320"/>
                 </a:solidFill>
                 <a:latin typeface="Karla"/>
               </a:rPr>
@@ -5631,7 +5631,7 @@
             <a:r>
               <a:rPr sz="1050" b="1" i="0" spc="160">
                 <a:solidFill>
-                  <a:srgbClr val="8A6420"/>
+                  <a:srgbClr val="3A3320"/>
                 </a:solidFill>
                 <a:latin typeface="Karla"/>
               </a:rPr>
@@ -5741,7 +5741,7 @@
             <a:avLst/>
           </a:prstGeom>
           <a:solidFill>
-            <a:srgbClr val="8A6420"/>
+            <a:srgbClr val="DBA62F"/>
           </a:solidFill>
           <a:ln>
             <a:noFill/>
@@ -5803,7 +5803,7 @@
             <a:r>
               <a:rPr sz="1150" b="1" i="0">
                 <a:solidFill>
-                  <a:srgbClr val="FFFDF7"/>
+                  <a:srgbClr val="3A3320"/>
                 </a:solidFill>
                 <a:latin typeface="Karla"/>
               </a:rPr>
@@ -5845,7 +5845,7 @@
             <a:r>
               <a:rPr sz="1300" b="1" i="0">
                 <a:solidFill>
-                  <a:srgbClr val="8A6420"/>
+                  <a:srgbClr val="3A3320"/>
                 </a:solidFill>
                 <a:latin typeface="Libre Caslon Display"/>
               </a:rPr>
@@ -5955,7 +5955,7 @@
             <a:avLst/>
           </a:prstGeom>
           <a:solidFill>
-            <a:srgbClr val="8A6420"/>
+            <a:srgbClr val="DBA62F"/>
           </a:solidFill>
           <a:ln>
             <a:noFill/>
@@ -6017,7 +6017,7 @@
             <a:r>
               <a:rPr sz="1150" b="1" i="0">
                 <a:solidFill>
-                  <a:srgbClr val="FFFDF7"/>
+                  <a:srgbClr val="3A3320"/>
                 </a:solidFill>
                 <a:latin typeface="Karla"/>
               </a:rPr>
@@ -6059,7 +6059,7 @@
             <a:r>
               <a:rPr sz="1300" b="1" i="0">
                 <a:solidFill>
-                  <a:srgbClr val="8A6420"/>
+                  <a:srgbClr val="3A3320"/>
                 </a:solidFill>
                 <a:latin typeface="Libre Caslon Display"/>
               </a:rPr>
@@ -6169,7 +6169,7 @@
             <a:avLst/>
           </a:prstGeom>
           <a:solidFill>
-            <a:srgbClr val="8A6420"/>
+            <a:srgbClr val="DBA62F"/>
           </a:solidFill>
           <a:ln>
             <a:noFill/>
@@ -6231,7 +6231,7 @@
             <a:r>
               <a:rPr sz="1150" b="1" i="0">
                 <a:solidFill>
-                  <a:srgbClr val="FFFDF7"/>
+                  <a:srgbClr val="3A3320"/>
                 </a:solidFill>
                 <a:latin typeface="Karla"/>
               </a:rPr>
@@ -6273,7 +6273,7 @@
             <a:r>
               <a:rPr sz="1300" b="1" i="0">
                 <a:solidFill>
-                  <a:srgbClr val="8A6420"/>
+                  <a:srgbClr val="3A3320"/>
                 </a:solidFill>
                 <a:latin typeface="Libre Caslon Display"/>
               </a:rPr>
@@ -6357,7 +6357,7 @@
             <a:r>
               <a:rPr sz="1200" b="0" i="1">
                 <a:solidFill>
-                  <a:srgbClr val="8A6420"/>
+                  <a:srgbClr val="3A3320"/>
                 </a:solidFill>
                 <a:latin typeface="Karla"/>
               </a:rPr>
@@ -6611,7 +6611,7 @@
             <a:r>
               <a:rPr sz="1050" b="1" i="0" spc="160">
                 <a:solidFill>
-                  <a:srgbClr val="8A6420"/>
+                  <a:srgbClr val="3A3320"/>
                 </a:solidFill>
                 <a:latin typeface="Karla"/>
               </a:rPr>
@@ -6721,7 +6721,7 @@
             <a:avLst/>
           </a:prstGeom>
           <a:solidFill>
-            <a:srgbClr val="8A6420"/>
+            <a:srgbClr val="DBA62F"/>
           </a:solidFill>
           <a:ln>
             <a:noFill/>
@@ -6783,7 +6783,7 @@
             <a:r>
               <a:rPr sz="1150" b="1" i="0">
                 <a:solidFill>
-                  <a:srgbClr val="FFFDF7"/>
+                  <a:srgbClr val="3A3320"/>
                 </a:solidFill>
                 <a:latin typeface="Karla"/>
               </a:rPr>
@@ -6825,7 +6825,7 @@
             <a:r>
               <a:rPr sz="1300" b="1" i="0">
                 <a:solidFill>
-                  <a:srgbClr val="8A6420"/>
+                  <a:srgbClr val="3A3320"/>
                 </a:solidFill>
                 <a:latin typeface="Libre Caslon Display"/>
               </a:rPr>
@@ -6935,7 +6935,7 @@
             <a:avLst/>
           </a:prstGeom>
           <a:solidFill>
-            <a:srgbClr val="8A6420"/>
+            <a:srgbClr val="DBA62F"/>
           </a:solidFill>
           <a:ln>
             <a:noFill/>
@@ -6997,7 +6997,7 @@
             <a:r>
               <a:rPr sz="1150" b="1" i="0">
                 <a:solidFill>
-                  <a:srgbClr val="FFFDF7"/>
+                  <a:srgbClr val="3A3320"/>
                 </a:solidFill>
                 <a:latin typeface="Karla"/>
               </a:rPr>
@@ -7039,7 +7039,7 @@
             <a:r>
               <a:rPr sz="1300" b="1" i="0">
                 <a:solidFill>
-                  <a:srgbClr val="8A6420"/>
+                  <a:srgbClr val="3A3320"/>
                 </a:solidFill>
                 <a:latin typeface="Libre Caslon Display"/>
               </a:rPr>
@@ -7149,7 +7149,7 @@
             <a:avLst/>
           </a:prstGeom>
           <a:solidFill>
-            <a:srgbClr val="8A6420"/>
+            <a:srgbClr val="DBA62F"/>
           </a:solidFill>
           <a:ln>
             <a:noFill/>
@@ -7211,7 +7211,7 @@
             <a:r>
               <a:rPr sz="1150" b="1" i="0">
                 <a:solidFill>
-                  <a:srgbClr val="FFFDF7"/>
+                  <a:srgbClr val="3A3320"/>
                 </a:solidFill>
                 <a:latin typeface="Karla"/>
               </a:rPr>
@@ -7253,7 +7253,7 @@
             <a:r>
               <a:rPr sz="1300" b="1" i="0">
                 <a:solidFill>
-                  <a:srgbClr val="8A6420"/>
+                  <a:srgbClr val="3A3320"/>
                 </a:solidFill>
                 <a:latin typeface="Libre Caslon Display"/>
               </a:rPr>
@@ -7337,7 +7337,7 @@
             <a:r>
               <a:rPr sz="1200" b="0" i="1">
                 <a:solidFill>
-                  <a:srgbClr val="8A6420"/>
+                  <a:srgbClr val="3A3320"/>
                 </a:solidFill>
                 <a:latin typeface="Karla"/>
               </a:rPr>
@@ -7591,7 +7591,7 @@
             <a:r>
               <a:rPr sz="1050" b="1" i="0" spc="160">
                 <a:solidFill>
-                  <a:srgbClr val="8A6420"/>
+                  <a:srgbClr val="3A3320"/>
                 </a:solidFill>
                 <a:latin typeface="Karla"/>
               </a:rPr>
@@ -7701,7 +7701,7 @@
             <a:avLst/>
           </a:prstGeom>
           <a:solidFill>
-            <a:srgbClr val="8A6420"/>
+            <a:srgbClr val="DBA62F"/>
           </a:solidFill>
           <a:ln>
             <a:noFill/>
@@ -7763,7 +7763,7 @@
             <a:r>
               <a:rPr sz="1150" b="1" i="0">
                 <a:solidFill>
-                  <a:srgbClr val="FFFDF7"/>
+                  <a:srgbClr val="3A3320"/>
                 </a:solidFill>
                 <a:latin typeface="Karla"/>
               </a:rPr>
@@ -7805,7 +7805,7 @@
             <a:r>
               <a:rPr sz="1300" b="1" i="0">
                 <a:solidFill>
-                  <a:srgbClr val="8A6420"/>
+                  <a:srgbClr val="3A3320"/>
                 </a:solidFill>
                 <a:latin typeface="Libre Caslon Display"/>
               </a:rPr>
@@ -7915,7 +7915,7 @@
             <a:avLst/>
           </a:prstGeom>
           <a:solidFill>
-            <a:srgbClr val="8A6420"/>
+            <a:srgbClr val="DBA62F"/>
           </a:solidFill>
           <a:ln>
             <a:noFill/>
@@ -7977,7 +7977,7 @@
             <a:r>
               <a:rPr sz="1150" b="1" i="0">
                 <a:solidFill>
-                  <a:srgbClr val="FFFDF7"/>
+                  <a:srgbClr val="3A3320"/>
                 </a:solidFill>
                 <a:latin typeface="Karla"/>
               </a:rPr>
@@ -8019,7 +8019,7 @@
             <a:r>
               <a:rPr sz="1300" b="1" i="0">
                 <a:solidFill>
-                  <a:srgbClr val="8A6420"/>
+                  <a:srgbClr val="3A3320"/>
                 </a:solidFill>
                 <a:latin typeface="Libre Caslon Display"/>
               </a:rPr>
@@ -8129,7 +8129,7 @@
             <a:avLst/>
           </a:prstGeom>
           <a:solidFill>
-            <a:srgbClr val="8A6420"/>
+            <a:srgbClr val="DBA62F"/>
           </a:solidFill>
           <a:ln>
             <a:noFill/>
@@ -8191,7 +8191,7 @@
             <a:r>
               <a:rPr sz="1150" b="1" i="0">
                 <a:solidFill>
-                  <a:srgbClr val="FFFDF7"/>
+                  <a:srgbClr val="3A3320"/>
                 </a:solidFill>
                 <a:latin typeface="Karla"/>
               </a:rPr>
@@ -8233,7 +8233,7 @@
             <a:r>
               <a:rPr sz="1300" b="1" i="0">
                 <a:solidFill>
-                  <a:srgbClr val="8A6420"/>
+                  <a:srgbClr val="3A3320"/>
                 </a:solidFill>
                 <a:latin typeface="Libre Caslon Display"/>
               </a:rPr>
@@ -8317,7 +8317,7 @@
             <a:r>
               <a:rPr sz="1200" b="0" i="1">
                 <a:solidFill>
-                  <a:srgbClr val="8A6420"/>
+                  <a:srgbClr val="3A3320"/>
                 </a:solidFill>
                 <a:latin typeface="Karla"/>
               </a:rPr>
@@ -8571,7 +8571,7 @@
             <a:r>
               <a:rPr sz="1050" b="1" i="0" spc="160">
                 <a:solidFill>
-                  <a:srgbClr val="8A6420"/>
+                  <a:srgbClr val="3A3320"/>
                 </a:solidFill>
                 <a:latin typeface="Karla"/>
               </a:rPr>
@@ -8681,7 +8681,7 @@
             <a:avLst/>
           </a:prstGeom>
           <a:solidFill>
-            <a:srgbClr val="8A6420"/>
+            <a:srgbClr val="DBA62F"/>
           </a:solidFill>
           <a:ln>
             <a:noFill/>
@@ -8767,7 +8767,7 @@
             <a:r>
               <a:rPr sz="1350" b="1" i="0">
                 <a:solidFill>
-                  <a:srgbClr val="8A6420"/>
+                  <a:srgbClr val="3A3320"/>
                 </a:solidFill>
                 <a:latin typeface="Libre Caslon Display"/>
               </a:rPr>
@@ -8877,7 +8877,7 @@
             <a:avLst/>
           </a:prstGeom>
           <a:solidFill>
-            <a:srgbClr val="8A6420"/>
+            <a:srgbClr val="DBA62F"/>
           </a:solidFill>
           <a:ln>
             <a:noFill/>
@@ -8963,7 +8963,7 @@
             <a:r>
               <a:rPr sz="1350" b="1" i="0">
                 <a:solidFill>
-                  <a:srgbClr val="8A6420"/>
+                  <a:srgbClr val="3A3320"/>
                 </a:solidFill>
                 <a:latin typeface="Libre Caslon Display"/>
               </a:rPr>
@@ -9073,7 +9073,7 @@
             <a:avLst/>
           </a:prstGeom>
           <a:solidFill>
-            <a:srgbClr val="8A6420"/>
+            <a:srgbClr val="DBA62F"/>
           </a:solidFill>
           <a:ln>
             <a:noFill/>
@@ -9159,7 +9159,7 @@
             <a:r>
               <a:rPr sz="1350" b="1" i="0">
                 <a:solidFill>
-                  <a:srgbClr val="8A6420"/>
+                  <a:srgbClr val="3A3320"/>
                 </a:solidFill>
                 <a:latin typeface="Libre Caslon Display"/>
               </a:rPr>
@@ -9243,7 +9243,7 @@
             <a:r>
               <a:rPr sz="1200" b="0" i="1">
                 <a:solidFill>
-                  <a:srgbClr val="8A6420"/>
+                  <a:srgbClr val="3A3320"/>
                 </a:solidFill>
                 <a:latin typeface="Karla"/>
               </a:rPr>
@@ -9497,7 +9497,7 @@
             <a:r>
               <a:rPr sz="1050" b="1" i="0" spc="160">
                 <a:solidFill>
-                  <a:srgbClr val="8A6420"/>
+                  <a:srgbClr val="3A3320"/>
                 </a:solidFill>
                 <a:latin typeface="Karla"/>
               </a:rPr>
@@ -9625,7 +9625,7 @@
             <a:r>
               <a:rPr sz="1150" b="1" i="0" spc="140">
                 <a:solidFill>
-                  <a:srgbClr val="8A6420"/>
+                  <a:srgbClr val="3A3320"/>
                 </a:solidFill>
                 <a:latin typeface="Karla"/>
               </a:rPr>
@@ -9649,7 +9649,7 @@
             <a:avLst/>
           </a:prstGeom>
           <a:solidFill>
-            <a:srgbClr val="8A6420"/>
+            <a:srgbClr val="DBA62F"/>
           </a:solidFill>
           <a:ln>
             <a:noFill/>
@@ -9735,7 +9735,7 @@
             <a:r>
               <a:rPr sz="1350" b="1" i="0">
                 <a:solidFill>
-                  <a:srgbClr val="8A6420"/>
+                  <a:srgbClr val="3A3320"/>
                 </a:solidFill>
                 <a:latin typeface="Libre Caslon Display"/>
               </a:rPr>
@@ -9821,7 +9821,7 @@
             <a:r>
               <a:rPr sz="1150" b="1" i="0" spc="140">
                 <a:solidFill>
-                  <a:srgbClr val="8A6420"/>
+                  <a:srgbClr val="3A3320"/>
                 </a:solidFill>
                 <a:latin typeface="Karla"/>
               </a:rPr>
@@ -9845,7 +9845,7 @@
             <a:avLst/>
           </a:prstGeom>
           <a:solidFill>
-            <a:srgbClr val="8A6420"/>
+            <a:srgbClr val="DBA62F"/>
           </a:solidFill>
           <a:ln>
             <a:noFill/>
@@ -9931,7 +9931,7 @@
             <a:r>
               <a:rPr sz="1350" b="1" i="0">
                 <a:solidFill>
-                  <a:srgbClr val="8A6420"/>
+                  <a:srgbClr val="3A3320"/>
                 </a:solidFill>
                 <a:latin typeface="Libre Caslon Display"/>
               </a:rPr>
@@ -10017,7 +10017,7 @@
             <a:r>
               <a:rPr sz="1150" b="1" i="0" spc="140">
                 <a:solidFill>
-                  <a:srgbClr val="8A6420"/>
+                  <a:srgbClr val="3A3320"/>
                 </a:solidFill>
                 <a:latin typeface="Karla"/>
               </a:rPr>
@@ -10041,7 +10041,7 @@
             <a:avLst/>
           </a:prstGeom>
           <a:solidFill>
-            <a:srgbClr val="8A6420"/>
+            <a:srgbClr val="DBA62F"/>
           </a:solidFill>
           <a:ln>
             <a:noFill/>
@@ -10127,7 +10127,7 @@
             <a:r>
               <a:rPr sz="1350" b="1" i="0">
                 <a:solidFill>
-                  <a:srgbClr val="8A6420"/>
+                  <a:srgbClr val="3A3320"/>
                 </a:solidFill>
                 <a:latin typeface="Libre Caslon Display"/>
               </a:rPr>
@@ -10213,7 +10213,7 @@
             <a:r>
               <a:rPr sz="1150" b="1" i="0" spc="140">
                 <a:solidFill>
-                  <a:srgbClr val="8A6420"/>
+                  <a:srgbClr val="3A3320"/>
                 </a:solidFill>
                 <a:latin typeface="Karla"/>
               </a:rPr>
@@ -10237,7 +10237,7 @@
             <a:avLst/>
           </a:prstGeom>
           <a:solidFill>
-            <a:srgbClr val="8A6420"/>
+            <a:srgbClr val="DBA62F"/>
           </a:solidFill>
           <a:ln>
             <a:noFill/>
@@ -10323,7 +10323,7 @@
             <a:r>
               <a:rPr sz="1350" b="1" i="0">
                 <a:solidFill>
-                  <a:srgbClr val="8A6420"/>
+                  <a:srgbClr val="3A3320"/>
                 </a:solidFill>
                 <a:latin typeface="Libre Caslon Display"/>
               </a:rPr>
@@ -10409,7 +10409,7 @@
             <a:r>
               <a:rPr sz="1150" b="1" i="0" spc="140">
                 <a:solidFill>
-                  <a:srgbClr val="8A6420"/>
+                  <a:srgbClr val="3A3320"/>
                 </a:solidFill>
                 <a:latin typeface="Karla"/>
               </a:rPr>
@@ -10433,7 +10433,7 @@
             <a:avLst/>
           </a:prstGeom>
           <a:solidFill>
-            <a:srgbClr val="8A6420"/>
+            <a:srgbClr val="DBA62F"/>
           </a:solidFill>
           <a:ln>
             <a:noFill/>
@@ -10519,7 +10519,7 @@
             <a:r>
               <a:rPr sz="1350" b="1" i="0">
                 <a:solidFill>
-                  <a:srgbClr val="8A6420"/>
+                  <a:srgbClr val="3A3320"/>
                 </a:solidFill>
                 <a:latin typeface="Libre Caslon Display"/>
               </a:rPr>
@@ -10561,7 +10561,7 @@
             <a:r>
               <a:rPr sz="1200" b="0" i="1">
                 <a:solidFill>
-                  <a:srgbClr val="8A6420"/>
+                  <a:srgbClr val="3A3320"/>
                 </a:solidFill>
                 <a:latin typeface="Karla"/>
               </a:rPr>

</xml_diff>